<commit_message>
deck 3-1 author review band P2: timing rebalance to 65, overlap audit fixes
- TIMING redistributed across 25 slides, total exactly 65 minutes
- four text-shape overlaps fixed (s-07 HTTPS label, s-09 changes label, s-19 canary split percent labels)
- full blocking audit green: 25 slides, zero duplicate zip entries, 0 OPC/schema findings, no run under 20pt, no wrap=none, nothing past y=6.95 but FooterBand, no straight connector with both dimensions, sections cover all slides exactly once

Co-Authored-By: Claude Opus 5 <noreply@anthropic.com>
</commit_message>
<xml_diff>
--- a/course/lectures/act-3-software-in-the-world/02-compute-environments-and-deployment/3-1-Compute-Environments-and-Deployment.pptx
+++ b/course/lectures/act-3-software-in-the-world/02-compute-environments-and-deployment/3-1-Compute-Environments-and-Deployment.pptx
@@ -1884,7 +1884,7 @@
           <a:lstStyle/>
           <a:p>
             <a:r>
-              <a:t>TIMING: 3 minutes. THE COMPARISON TABLE, retained from the source deck's summary slide; the three detail slides follow.</a:t>
+              <a:t>TIMING: 2 minutes. THE COMPARISON TABLE, retained from the source deck's summary slide; the three detail slides follow.</a:t>
             </a:r>
           </a:p>
           <a:p>
@@ -3289,7 +3289,7 @@
           <a:lstStyle/>
           <a:p>
             <a:r>
-              <a:t>TIMING: 3 minutes. THE DISTINCTION CI/CD WILL DEPEND ON.</a:t>
+              <a:t>TIMING: 2 minutes. THE DISTINCTION CI/CD WILL DEPEND ON.</a:t>
             </a:r>
           </a:p>
           <a:p>
@@ -15001,8 +15001,8 @@
         </p:nvSpPr>
         <p:spPr>
           <a:xfrm>
-            <a:off x="4572000" y="932688"/>
-            <a:ext cx="731520" cy="310896"/>
+            <a:off x="4553712" y="932688"/>
+            <a:ext cx="502920" cy="310896"/>
           </a:xfrm>
           <a:prstGeom prst="rect">
             <a:avLst/>
@@ -15051,8 +15051,8 @@
         </p:nvSpPr>
         <p:spPr>
           <a:xfrm>
-            <a:off x="4572000" y="2615184"/>
-            <a:ext cx="731520" cy="310896"/>
+            <a:off x="4553712" y="2615184"/>
+            <a:ext cx="502920" cy="310896"/>
           </a:xfrm>
           <a:prstGeom prst="rect">
             <a:avLst/>
@@ -22183,8 +22183,8 @@
         </p:nvSpPr>
         <p:spPr>
           <a:xfrm>
-            <a:off x="1325880" y="2697480"/>
-            <a:ext cx="1188720" cy="329184"/>
+            <a:off x="1188720" y="2724912"/>
+            <a:ext cx="914400" cy="329184"/>
           </a:xfrm>
           <a:prstGeom prst="rect">
             <a:avLst/>
@@ -25027,8 +25027,8 @@
         </p:nvSpPr>
         <p:spPr>
           <a:xfrm>
-            <a:off x="3931920" y="2706624"/>
-            <a:ext cx="1645920" cy="365760"/>
+            <a:off x="4160520" y="2706624"/>
+            <a:ext cx="1188720" cy="365760"/>
           </a:xfrm>
           <a:prstGeom prst="rect">
             <a:avLst/>

</xml_diff>